<commit_message>
docs: add SOAP Java mobile login capture
</commit_message>
<xml_diff>
--- a/TI.1.1. PAO202651_SOAP_JAVA_SINBDD_NRC36884_GR09/05. DOCUMENTACION/02. MANUAL TECNICO/MANUAL_SOAP_JAVA_SINBDD_GR09.pptx
+++ b/TI.1.1. PAO202651_SOAP_JAVA_SINBDD_NRC36884_GR09/05. DOCUMENTACION/02. MANUAL TECNICO/MANUAL_SOAP_JAVA_SINBDD_GR09.pptx
@@ -2,64 +2,64 @@
 <file path=ppt/presentation.xml><?xml version="1.0" encoding="utf-8"?>
 <p:presentation xmlns:p="http://schemas.openxmlformats.org/presentationml/2006/main" embedTrueTypeFonts="1" saveSubsetFonts="1">
   <p:sldMasterIdLst>
-    <p:sldMasterId xmlns:r="http://schemas.openxmlformats.org/officeDocument/2006/relationships" id="2147483648" r:id="R09a7f7b68e2a4321"/>
+    <p:sldMasterId xmlns:r="http://schemas.openxmlformats.org/officeDocument/2006/relationships" id="2147483648" r:id="R26da11b4da004cba"/>
   </p:sldMasterIdLst>
   <p:notesMasterIdLst>
-    <p:notesMasterId xmlns:r="http://schemas.openxmlformats.org/officeDocument/2006/relationships" r:id="R97dbba94bcf44d61"/>
+    <p:notesMasterId xmlns:r="http://schemas.openxmlformats.org/officeDocument/2006/relationships" r:id="R873b4ab0118a485f"/>
   </p:notesMasterIdLst>
   <p:sldIdLst>
-    <p:sldId xmlns:r="http://schemas.openxmlformats.org/officeDocument/2006/relationships" id="256" r:id="Re38131785521400b"/>
-    <p:sldId xmlns:r="http://schemas.openxmlformats.org/officeDocument/2006/relationships" id="257" r:id="R448dca0d9211416b"/>
-    <p:sldId xmlns:r="http://schemas.openxmlformats.org/officeDocument/2006/relationships" id="258" r:id="Rfad29747d35f4797"/>
-    <p:sldId xmlns:r="http://schemas.openxmlformats.org/officeDocument/2006/relationships" id="259" r:id="R2e80908078044aef"/>
-    <p:sldId xmlns:r="http://schemas.openxmlformats.org/officeDocument/2006/relationships" id="260" r:id="R947847321ec545e3"/>
-    <p:sldId xmlns:r="http://schemas.openxmlformats.org/officeDocument/2006/relationships" id="261" r:id="Rb3d21937ba04450e"/>
-    <p:sldId xmlns:r="http://schemas.openxmlformats.org/officeDocument/2006/relationships" id="262" r:id="R93b90d19255a4fa7"/>
-    <p:sldId xmlns:r="http://schemas.openxmlformats.org/officeDocument/2006/relationships" id="263" r:id="Rfe71790f074f4af1"/>
-    <p:sldId xmlns:r="http://schemas.openxmlformats.org/officeDocument/2006/relationships" id="264" r:id="Rcf6798ca63294450"/>
-    <p:sldId xmlns:r="http://schemas.openxmlformats.org/officeDocument/2006/relationships" id="265" r:id="R3f9b203bdb3b4b71"/>
-    <p:sldId xmlns:r="http://schemas.openxmlformats.org/officeDocument/2006/relationships" id="266" r:id="R56ea9798884f428c"/>
-    <p:sldId xmlns:r="http://schemas.openxmlformats.org/officeDocument/2006/relationships" id="267" r:id="R461aacf5923f41d8"/>
-    <p:sldId xmlns:r="http://schemas.openxmlformats.org/officeDocument/2006/relationships" id="268" r:id="Rc33b7f47892c421c"/>
-    <p:sldId xmlns:r="http://schemas.openxmlformats.org/officeDocument/2006/relationships" id="269" r:id="R31a5a9258f914e65"/>
-    <p:sldId xmlns:r="http://schemas.openxmlformats.org/officeDocument/2006/relationships" id="270" r:id="R8b5b952c9706404e"/>
-    <p:sldId xmlns:r="http://schemas.openxmlformats.org/officeDocument/2006/relationships" id="271" r:id="Ra655116e6368429a"/>
-    <p:sldId xmlns:r="http://schemas.openxmlformats.org/officeDocument/2006/relationships" id="272" r:id="R130a15e796444cc4"/>
-    <p:sldId xmlns:r="http://schemas.openxmlformats.org/officeDocument/2006/relationships" id="273" r:id="Re600c1d1102144a6"/>
-    <p:sldId xmlns:r="http://schemas.openxmlformats.org/officeDocument/2006/relationships" id="274" r:id="Rec65b488b13e4af6"/>
-    <p:sldId xmlns:r="http://schemas.openxmlformats.org/officeDocument/2006/relationships" id="275" r:id="R0f4164717c444c91"/>
-    <p:sldId xmlns:r="http://schemas.openxmlformats.org/officeDocument/2006/relationships" id="276" r:id="Rbc00ad3191374766"/>
-    <p:sldId xmlns:r="http://schemas.openxmlformats.org/officeDocument/2006/relationships" id="277" r:id="R4d933dbcdb8b4756"/>
-    <p:sldId xmlns:r="http://schemas.openxmlformats.org/officeDocument/2006/relationships" id="278" r:id="Re028a64891074654"/>
-    <p:sldId xmlns:r="http://schemas.openxmlformats.org/officeDocument/2006/relationships" id="279" r:id="R6c9ee9436e6c4b6c"/>
-    <p:sldId xmlns:r="http://schemas.openxmlformats.org/officeDocument/2006/relationships" id="280" r:id="R246b855c55d244a8"/>
-    <p:sldId xmlns:r="http://schemas.openxmlformats.org/officeDocument/2006/relationships" id="281" r:id="R9c3e0202c2a14480"/>
-    <p:sldId xmlns:r="http://schemas.openxmlformats.org/officeDocument/2006/relationships" id="282" r:id="R7b885ce488984ea7"/>
-    <p:sldId xmlns:r="http://schemas.openxmlformats.org/officeDocument/2006/relationships" id="283" r:id="R8c48d52d213247ab"/>
-    <p:sldId xmlns:r="http://schemas.openxmlformats.org/officeDocument/2006/relationships" id="284" r:id="Ra228ff826f694a91"/>
-    <p:sldId xmlns:r="http://schemas.openxmlformats.org/officeDocument/2006/relationships" id="285" r:id="Rd39f4d873b254597"/>
+    <p:sldId xmlns:r="http://schemas.openxmlformats.org/officeDocument/2006/relationships" id="256" r:id="R549bb5703eb14d19"/>
+    <p:sldId xmlns:r="http://schemas.openxmlformats.org/officeDocument/2006/relationships" id="257" r:id="Red92f4667a2d422d"/>
+    <p:sldId xmlns:r="http://schemas.openxmlformats.org/officeDocument/2006/relationships" id="258" r:id="R4ee0270d3373458f"/>
+    <p:sldId xmlns:r="http://schemas.openxmlformats.org/officeDocument/2006/relationships" id="259" r:id="R058b9a370c544cbd"/>
+    <p:sldId xmlns:r="http://schemas.openxmlformats.org/officeDocument/2006/relationships" id="260" r:id="Ra21f4973b51a4a45"/>
+    <p:sldId xmlns:r="http://schemas.openxmlformats.org/officeDocument/2006/relationships" id="261" r:id="R558a7a0df1724dac"/>
+    <p:sldId xmlns:r="http://schemas.openxmlformats.org/officeDocument/2006/relationships" id="262" r:id="Rad410bb928524d3b"/>
+    <p:sldId xmlns:r="http://schemas.openxmlformats.org/officeDocument/2006/relationships" id="263" r:id="R6fb918d788aa4085"/>
+    <p:sldId xmlns:r="http://schemas.openxmlformats.org/officeDocument/2006/relationships" id="264" r:id="R50e9ed491b4a486a"/>
+    <p:sldId xmlns:r="http://schemas.openxmlformats.org/officeDocument/2006/relationships" id="265" r:id="R53661b5369e543f4"/>
+    <p:sldId xmlns:r="http://schemas.openxmlformats.org/officeDocument/2006/relationships" id="266" r:id="R00c9cb490f8c426c"/>
+    <p:sldId xmlns:r="http://schemas.openxmlformats.org/officeDocument/2006/relationships" id="267" r:id="Ra89cca1b6ba04a32"/>
+    <p:sldId xmlns:r="http://schemas.openxmlformats.org/officeDocument/2006/relationships" id="268" r:id="R57ce86357e5741a1"/>
+    <p:sldId xmlns:r="http://schemas.openxmlformats.org/officeDocument/2006/relationships" id="269" r:id="Redc758d0f5f2422e"/>
+    <p:sldId xmlns:r="http://schemas.openxmlformats.org/officeDocument/2006/relationships" id="270" r:id="R456df3ee85ef44ad"/>
+    <p:sldId xmlns:r="http://schemas.openxmlformats.org/officeDocument/2006/relationships" id="271" r:id="R61cbd97b764b4f23"/>
+    <p:sldId xmlns:r="http://schemas.openxmlformats.org/officeDocument/2006/relationships" id="272" r:id="R402a7cafa1e44930"/>
+    <p:sldId xmlns:r="http://schemas.openxmlformats.org/officeDocument/2006/relationships" id="273" r:id="R678543abadaa4e9f"/>
+    <p:sldId xmlns:r="http://schemas.openxmlformats.org/officeDocument/2006/relationships" id="274" r:id="Rd4a164286c644083"/>
+    <p:sldId xmlns:r="http://schemas.openxmlformats.org/officeDocument/2006/relationships" id="275" r:id="R8b6c097bb924455c"/>
+    <p:sldId xmlns:r="http://schemas.openxmlformats.org/officeDocument/2006/relationships" id="276" r:id="R54c358587c414c23"/>
+    <p:sldId xmlns:r="http://schemas.openxmlformats.org/officeDocument/2006/relationships" id="277" r:id="R5a7569780a504767"/>
+    <p:sldId xmlns:r="http://schemas.openxmlformats.org/officeDocument/2006/relationships" id="278" r:id="R7474288524ef4665"/>
+    <p:sldId xmlns:r="http://schemas.openxmlformats.org/officeDocument/2006/relationships" id="279" r:id="R3d8e927f6fcf49c6"/>
+    <p:sldId xmlns:r="http://schemas.openxmlformats.org/officeDocument/2006/relationships" id="280" r:id="Reda468a73caf4813"/>
+    <p:sldId xmlns:r="http://schemas.openxmlformats.org/officeDocument/2006/relationships" id="281" r:id="R1341c91a722845c9"/>
+    <p:sldId xmlns:r="http://schemas.openxmlformats.org/officeDocument/2006/relationships" id="282" r:id="R11d074ee9f514368"/>
+    <p:sldId xmlns:r="http://schemas.openxmlformats.org/officeDocument/2006/relationships" id="283" r:id="R8f726f3de68e4297"/>
+    <p:sldId xmlns:r="http://schemas.openxmlformats.org/officeDocument/2006/relationships" id="284" r:id="R8cde2385df6f4f39"/>
+    <p:sldId xmlns:r="http://schemas.openxmlformats.org/officeDocument/2006/relationships" id="285" r:id="Rb1e250bc4a2b4d50"/>
   </p:sldIdLst>
   <p:sldSz cx="12192000" cy="6858000"/>
   <p:notesSz cx="6858000" cy="9144000"/>
   <p:embeddedFontLst>
     <p:embeddedFont>
       <p:font typeface="Calibri"/>
-      <p:regular xmlns:r="http://schemas.openxmlformats.org/officeDocument/2006/relationships" r:id="R8dc195dab60745c1"/>
-      <p:bold xmlns:r="http://schemas.openxmlformats.org/officeDocument/2006/relationships" r:id="R206604e782ba4653"/>
-      <p:italic xmlns:r="http://schemas.openxmlformats.org/officeDocument/2006/relationships" r:id="Rda23f731c9df4993"/>
-      <p:boldItalic xmlns:r="http://schemas.openxmlformats.org/officeDocument/2006/relationships" r:id="R2071f4eb349543d5"/>
+      <p:regular xmlns:r="http://schemas.openxmlformats.org/officeDocument/2006/relationships" r:id="R285948300b9c47bb"/>
+      <p:bold xmlns:r="http://schemas.openxmlformats.org/officeDocument/2006/relationships" r:id="Rb0c169e44b5b49d9"/>
+      <p:italic xmlns:r="http://schemas.openxmlformats.org/officeDocument/2006/relationships" r:id="Rf74def7c9a344060"/>
+      <p:boldItalic xmlns:r="http://schemas.openxmlformats.org/officeDocument/2006/relationships" r:id="R39a5591668f648f0"/>
     </p:embeddedFont>
     <p:embeddedFont>
       <p:font typeface="Cambria"/>
-      <p:regular xmlns:r="http://schemas.openxmlformats.org/officeDocument/2006/relationships" r:id="R0356c14e6bce4c34"/>
-      <p:bold xmlns:r="http://schemas.openxmlformats.org/officeDocument/2006/relationships" r:id="Rb28b8cb88ba34876"/>
-      <p:italic xmlns:r="http://schemas.openxmlformats.org/officeDocument/2006/relationships" r:id="R748122bd4bab447f"/>
-      <p:boldItalic xmlns:r="http://schemas.openxmlformats.org/officeDocument/2006/relationships" r:id="Ra46645f5c9ed4a16"/>
+      <p:regular xmlns:r="http://schemas.openxmlformats.org/officeDocument/2006/relationships" r:id="R494c7253bed64b82"/>
+      <p:bold xmlns:r="http://schemas.openxmlformats.org/officeDocument/2006/relationships" r:id="Rb891ec1cf69d4356"/>
+      <p:italic xmlns:r="http://schemas.openxmlformats.org/officeDocument/2006/relationships" r:id="R40908eecdf82458c"/>
+      <p:boldItalic xmlns:r="http://schemas.openxmlformats.org/officeDocument/2006/relationships" r:id="R628df45bb2d64481"/>
     </p:embeddedFont>
     <p:embeddedFont>
       <p:font typeface="Gill Sans"/>
-      <p:regular xmlns:r="http://schemas.openxmlformats.org/officeDocument/2006/relationships" r:id="R623ed82076ad436d"/>
-      <p:bold xmlns:r="http://schemas.openxmlformats.org/officeDocument/2006/relationships" r:id="Ra29721b618ba42d4"/>
+      <p:regular xmlns:r="http://schemas.openxmlformats.org/officeDocument/2006/relationships" r:id="R761cb82830344794"/>
+      <p:bold xmlns:r="http://schemas.openxmlformats.org/officeDocument/2006/relationships" r:id="R525f550e842946ea"/>
     </p:embeddedFont>
   </p:embeddedFontLst>
   <p:defaultTextStyle>
@@ -16349,17 +16349,17 @@
   </p:cSld>
   <p:clrMap bg1="lt1" tx1="dk1" bg2="dk2" tx2="lt2" accent1="accent1" accent2="accent2" accent3="accent3" accent4="accent4" accent5="accent5" accent6="accent6" hlink="hlink" folHlink="folHlink"/>
   <p:sldLayoutIdLst>
-    <p:sldLayoutId xmlns:r="http://schemas.openxmlformats.org/officeDocument/2006/relationships" id="2147483649" r:id="R06e5d4a508b043a0"/>
-    <p:sldLayoutId xmlns:r="http://schemas.openxmlformats.org/officeDocument/2006/relationships" id="2147483650" r:id="R9f327f23dc6444b1"/>
-    <p:sldLayoutId xmlns:r="http://schemas.openxmlformats.org/officeDocument/2006/relationships" id="2147483651" r:id="R16913efe8c6a47b4"/>
-    <p:sldLayoutId xmlns:r="http://schemas.openxmlformats.org/officeDocument/2006/relationships" id="2147483652" r:id="R4238b6aa28a94862"/>
-    <p:sldLayoutId xmlns:r="http://schemas.openxmlformats.org/officeDocument/2006/relationships" id="2147483653" r:id="Re48d9c9f93c049e8"/>
-    <p:sldLayoutId xmlns:r="http://schemas.openxmlformats.org/officeDocument/2006/relationships" id="2147483654" r:id="R47ea9c7ed50049a1"/>
-    <p:sldLayoutId xmlns:r="http://schemas.openxmlformats.org/officeDocument/2006/relationships" id="2147483655" r:id="R549f5e4060454aee"/>
-    <p:sldLayoutId xmlns:r="http://schemas.openxmlformats.org/officeDocument/2006/relationships" id="2147483656" r:id="Rfa2bd90d23c24adb"/>
-    <p:sldLayoutId xmlns:r="http://schemas.openxmlformats.org/officeDocument/2006/relationships" id="2147483657" r:id="R81c5531f85184ffc"/>
-    <p:sldLayoutId xmlns:r="http://schemas.openxmlformats.org/officeDocument/2006/relationships" id="2147483658" r:id="R497d4a6f534a44e8"/>
-    <p:sldLayoutId xmlns:r="http://schemas.openxmlformats.org/officeDocument/2006/relationships" id="2147483659" r:id="R1784d182fb9b4bbe"/>
+    <p:sldLayoutId xmlns:r="http://schemas.openxmlformats.org/officeDocument/2006/relationships" id="2147483649" r:id="R0ae94396ac51408c"/>
+    <p:sldLayoutId xmlns:r="http://schemas.openxmlformats.org/officeDocument/2006/relationships" id="2147483650" r:id="R94a8c6e1e75d41cf"/>
+    <p:sldLayoutId xmlns:r="http://schemas.openxmlformats.org/officeDocument/2006/relationships" id="2147483651" r:id="Rcb96ecdfd39448fa"/>
+    <p:sldLayoutId xmlns:r="http://schemas.openxmlformats.org/officeDocument/2006/relationships" id="2147483652" r:id="Raf507a31f806434a"/>
+    <p:sldLayoutId xmlns:r="http://schemas.openxmlformats.org/officeDocument/2006/relationships" id="2147483653" r:id="Rbe7cd5db62cd4cb6"/>
+    <p:sldLayoutId xmlns:r="http://schemas.openxmlformats.org/officeDocument/2006/relationships" id="2147483654" r:id="R14e2996ca22a4052"/>
+    <p:sldLayoutId xmlns:r="http://schemas.openxmlformats.org/officeDocument/2006/relationships" id="2147483655" r:id="R7652a24e2cac4cca"/>
+    <p:sldLayoutId xmlns:r="http://schemas.openxmlformats.org/officeDocument/2006/relationships" id="2147483656" r:id="R7f384143109c4c80"/>
+    <p:sldLayoutId xmlns:r="http://schemas.openxmlformats.org/officeDocument/2006/relationships" id="2147483657" r:id="R70ab80f6931541df"/>
+    <p:sldLayoutId xmlns:r="http://schemas.openxmlformats.org/officeDocument/2006/relationships" id="2147483658" r:id="R3c7b22194803417f"/>
+    <p:sldLayoutId xmlns:r="http://schemas.openxmlformats.org/officeDocument/2006/relationships" id="2147483659" r:id="Rf49e5ec060a94296"/>
   </p:sldLayoutIdLst>
   <p:hf sldNum="0" hdr="0" ftr="0" dt="0"/>
   <p:txStyles>
@@ -17495,7 +17495,7 @@
           <p:cNvPr id="98" name="Google Shape;98;p1">
             <a:extLst xmlns:a="http://schemas.openxmlformats.org/drawingml/2006/main">
               <a:ext uri="{FF2B5EF4-FFF2-40B4-BE49-F238E27FC236}">
-                <a16:creationId xmlns:a16="http://schemas.microsoft.com/office/drawing/2014/main" id="{E88FBA2A-5FD6-45C0-9265-6E37BD323333}"/>
+                <a16:creationId xmlns:a16="http://schemas.microsoft.com/office/drawing/2014/main" id="{0700C730-47AE-48BD-9CDC-EE9BE56DDADE}"/>
               </a:ext>
             </a:extLst>
           </p:cNvPr>
@@ -17505,7 +17505,7 @@
           <p:nvPr/>
         </p:nvPicPr>
         <p:blipFill rotWithShape="1">
-          <a:blip xmlns:r="http://schemas.openxmlformats.org/officeDocument/2006/relationships" xmlns:a="http://schemas.openxmlformats.org/drawingml/2006/main" r:embed="Reb050b23e0404fed">
+          <a:blip xmlns:r="http://schemas.openxmlformats.org/officeDocument/2006/relationships" xmlns:a="http://schemas.openxmlformats.org/drawingml/2006/main" r:embed="R9d03aaaed2d546bb">
             <a:alphaModFix/>
           </a:blip>
           <a:srcRect xmlns:a="http://schemas.openxmlformats.org/drawingml/2006/main" l="0" t="0" r="0" b="0"/>
@@ -26191,7 +26191,7 @@
           <p:cNvPr id="108" name="Google Shape;108;p2">
             <a:extLst xmlns:a="http://schemas.openxmlformats.org/drawingml/2006/main">
               <a:ext uri="{FF2B5EF4-FFF2-40B4-BE49-F238E27FC236}">
-                <a16:creationId xmlns:a16="http://schemas.microsoft.com/office/drawing/2014/main" id="{EED421CA-9957-4938-A6C5-1E76EEFBDC4A}"/>
+                <a16:creationId xmlns:a16="http://schemas.microsoft.com/office/drawing/2014/main" id="{A448AA95-83B5-4E76-9415-E7D14D2F3965}"/>
               </a:ext>
             </a:extLst>
           </p:cNvPr>
@@ -26201,7 +26201,7 @@
           <p:nvPr/>
         </p:nvPicPr>
         <p:blipFill rotWithShape="1">
-          <a:blip xmlns:r="http://schemas.openxmlformats.org/officeDocument/2006/relationships" xmlns:a="http://schemas.openxmlformats.org/drawingml/2006/main" r:embed="Rde4d17f64ceb4d97">
+          <a:blip xmlns:r="http://schemas.openxmlformats.org/officeDocument/2006/relationships" xmlns:a="http://schemas.openxmlformats.org/drawingml/2006/main" r:embed="R54f0c353110a421a">
             <a:alphaModFix/>
           </a:blip>
           <a:srcRect xmlns:a="http://schemas.openxmlformats.org/drawingml/2006/main" l="0" t="0" r="0" b="0"/>
@@ -28340,7 +28340,7 @@
           <p:cNvPr id="413" name="">
             <a:extLst xmlns:a="http://schemas.openxmlformats.org/drawingml/2006/main">
               <a:ext uri="{FF2B5EF4-FFF2-40B4-BE49-F238E27FC236}">
-                <a16:creationId xmlns:a16="http://schemas.microsoft.com/office/drawing/2014/main" id="{4BDC1638-3C05-445F-AC19-6B89E35F1EFA}"/>
+                <a16:creationId xmlns:a16="http://schemas.microsoft.com/office/drawing/2014/main" id="{B05DB5E7-F493-4DBC-857B-5D797F7C495E}"/>
               </a:ext>
             </a:extLst>
           </p:cNvPr>
@@ -28350,7 +28350,7 @@
           <p:nvPr/>
         </p:nvPicPr>
         <p:blipFill>
-          <a:blip xmlns:r="http://schemas.openxmlformats.org/officeDocument/2006/relationships" xmlns:a="http://schemas.openxmlformats.org/drawingml/2006/main" r:embed="R8d751b16adba4fee"/>
+          <a:blip xmlns:r="http://schemas.openxmlformats.org/officeDocument/2006/relationships" xmlns:a="http://schemas.openxmlformats.org/drawingml/2006/main" r:embed="Rd12d9326863d4370"/>
           <a:stretch xmlns:a="http://schemas.openxmlformats.org/drawingml/2006/main"/>
         </p:blipFill>
         <p:spPr>
@@ -29032,7 +29032,7 @@
           <p:cNvPr id="421" name="">
             <a:extLst xmlns:a="http://schemas.openxmlformats.org/drawingml/2006/main">
               <a:ext uri="{FF2B5EF4-FFF2-40B4-BE49-F238E27FC236}">
-                <a16:creationId xmlns:a16="http://schemas.microsoft.com/office/drawing/2014/main" id="{14AB9C3F-E018-4B5F-A1B9-24A0DA3A5FB4}"/>
+                <a16:creationId xmlns:a16="http://schemas.microsoft.com/office/drawing/2014/main" id="{4735346D-12C6-4A4B-9AA5-F37A02C44A3C}"/>
               </a:ext>
             </a:extLst>
           </p:cNvPr>
@@ -29042,7 +29042,7 @@
           <p:nvPr/>
         </p:nvPicPr>
         <p:blipFill>
-          <a:blip xmlns:r="http://schemas.openxmlformats.org/officeDocument/2006/relationships" xmlns:a="http://schemas.openxmlformats.org/drawingml/2006/main" r:embed="Ra9d90f313ed748eb"/>
+          <a:blip xmlns:r="http://schemas.openxmlformats.org/officeDocument/2006/relationships" xmlns:a="http://schemas.openxmlformats.org/drawingml/2006/main" r:embed="R0c97989e15304e0c"/>
           <a:stretch xmlns:a="http://schemas.openxmlformats.org/drawingml/2006/main"/>
         </p:blipFill>
         <p:spPr>
@@ -32169,8 +32169,8 @@
         </p:nvSpPr>
         <p:spPr>
           <a:xfrm xmlns:a="http://schemas.openxmlformats.org/drawingml/2006/main">
-            <a:off x="491075" y="1294250"/>
-            <a:ext cx="3888600" cy="3217200"/>
+            <a:off x="491109" y="2047875"/>
+            <a:ext cx="3888581" cy="1285875"/>
           </a:xfrm>
           <a:prstGeom xmlns:a="http://schemas.openxmlformats.org/drawingml/2006/main" prst="rect">
             <a:avLst/>
@@ -32182,7 +32182,7 @@
         </p:spPr>
         <p:txBody>
           <a:bodyPr xmlns:a="http://schemas.openxmlformats.org/drawingml/2006/main" spcFirstLastPara="1" wrap="square" lIns="91425" tIns="45700" rIns="91425" bIns="45700" anchor="ctr">
-            <a:normAutofit/>
+            <a:normAutofit fontScale="100000"/>
           </a:bodyPr>
           <a:lstStyle xmlns:a="http://schemas.openxmlformats.org/drawingml/2006/main"/>
           <a:p xmlns:a="http://schemas.openxmlformats.org/drawingml/2006/main">
@@ -32205,30 +32205,38 @@
                 <a:ea typeface="Cambria"/>
                 <a:cs typeface="Cambria"/>
               </a:rPr>
-              <a:t>Vista: LoginActivity.java</a:t>
-            </a:r>
-          </a:p>
-          <a:p xmlns:a="http://schemas.openxmlformats.org/drawingml/2006/main">
-            <a:pPr marL="0" lvl="0" indent="0" algn="l">
-              <a:lnSpc>
-                <a:spcPct val="115000"/>
-              </a:lnSpc>
-              <a:spcBef>
-                <a:spcPts val="1200"/>
-              </a:spcBef>
-              <a:spcAft>
-                <a:spcPts val="0"/>
-              </a:spcAft>
-              <a:buSzPts val="1656"/>
-              <a:buNone/>
-            </a:pPr>
+              <a:t>Vista: </a:t>
+            </a:r>
             <a:r>
               <a:rPr sz="1564" b="1">
                 <a:latin typeface="Cambria"/>
                 <a:ea typeface="Cambria"/>
                 <a:cs typeface="Cambria"/>
               </a:rPr>
-              <a:t>Solicita las credenciales MONSTER / MONSTER9 y dirige a la conversión tras una respuesta válida.</a:t>
+              <a:t>ActividadInicioSesion.java</a:t>
+            </a:r>
+          </a:p>
+          <a:p xmlns:a="http://schemas.openxmlformats.org/drawingml/2006/main">
+            <a:pPr marL="0" lvl="0" indent="0" algn="l">
+              <a:lnSpc>
+                <a:spcPct val="115000"/>
+              </a:lnSpc>
+              <a:spcBef>
+                <a:spcPts val="1200"/>
+              </a:spcBef>
+              <a:spcAft>
+                <a:spcPts val="0"/>
+              </a:spcAft>
+              <a:buSzPts val="1656"/>
+              <a:buNone/>
+            </a:pPr>
+            <a:r>
+              <a:rPr sz="1564" b="1">
+                <a:latin typeface="Cambria"/>
+                <a:ea typeface="Cambria"/>
+                <a:cs typeface="Cambria"/>
+              </a:rPr>
+              <a:t>Solicita usuario y contraseña para acceder al conversor.</a:t>
             </a:r>
             <a:endParaRPr sz="1564" b="1">
               <a:latin typeface="Cambria"/>
@@ -32256,8 +32264,8 @@
         </p:nvSpPr>
         <p:spPr>
           <a:xfrm xmlns:a="http://schemas.openxmlformats.org/drawingml/2006/main">
-            <a:off x="4698075" y="1376600"/>
-            <a:ext cx="3888600" cy="3217200"/>
+            <a:off x="4698111" y="2047875"/>
+            <a:ext cx="3888581" cy="1285875"/>
           </a:xfrm>
           <a:prstGeom xmlns:a="http://schemas.openxmlformats.org/drawingml/2006/main" prst="rect">
             <a:avLst/>
@@ -32269,7 +32277,7 @@
         </p:spPr>
         <p:txBody>
           <a:bodyPr xmlns:a="http://schemas.openxmlformats.org/drawingml/2006/main" spcFirstLastPara="1" wrap="square" lIns="91425" tIns="45700" rIns="91425" bIns="45700" anchor="ctr">
-            <a:normAutofit/>
+            <a:normAutofit fontScale="100000"/>
           </a:bodyPr>
           <a:lstStyle xmlns:a="http://schemas.openxmlformats.org/drawingml/2006/main"/>
           <a:p xmlns:a="http://schemas.openxmlformats.org/drawingml/2006/main">
@@ -32292,30 +32300,38 @@
                 <a:ea typeface="Cambria"/>
                 <a:cs typeface="Cambria"/>
               </a:rPr>
-              <a:t>Vista: ConversionActivity.java</a:t>
-            </a:r>
-          </a:p>
-          <a:p xmlns:a="http://schemas.openxmlformats.org/drawingml/2006/main">
-            <a:pPr marL="0" lvl="0" indent="0" algn="l">
-              <a:lnSpc>
-                <a:spcPct val="115000"/>
-              </a:lnSpc>
-              <a:spcBef>
-                <a:spcPts val="1200"/>
-              </a:spcBef>
-              <a:spcAft>
-                <a:spcPts val="0"/>
-              </a:spcAft>
-              <a:buSzPts val="1656"/>
-              <a:buNone/>
-            </a:pPr>
+              <a:t>Vista: </a:t>
+            </a:r>
             <a:r>
               <a:rPr sz="1564" b="1">
                 <a:latin typeface="Cambria"/>
                 <a:ea typeface="Cambria"/>
                 <a:cs typeface="Cambria"/>
               </a:rPr>
-              <a:t>Permite elegir magnitud y unidades, ingresar el valor y consultar el resultado del servicio.</a:t>
+              <a:t>ActividadConversion.java</a:t>
+            </a:r>
+          </a:p>
+          <a:p xmlns:a="http://schemas.openxmlformats.org/drawingml/2006/main">
+            <a:pPr marL="0" lvl="0" indent="0" algn="l">
+              <a:lnSpc>
+                <a:spcPct val="115000"/>
+              </a:lnSpc>
+              <a:spcBef>
+                <a:spcPts val="1200"/>
+              </a:spcBef>
+              <a:spcAft>
+                <a:spcPts val="0"/>
+              </a:spcAft>
+              <a:buSzPts val="1656"/>
+              <a:buNone/>
+            </a:pPr>
+            <a:r>
+              <a:rPr sz="1564" b="1">
+                <a:latin typeface="Cambria"/>
+                <a:ea typeface="Cambria"/>
+                <a:cs typeface="Cambria"/>
+              </a:rPr>
+              <a:t>Permite elegir magnitud, unidades y valor para consultar el resultado.</a:t>
             </a:r>
             <a:endParaRPr sz="1564" b="1">
               <a:latin typeface="Cambria"/>
@@ -32435,8 +32451,8 @@
         </p:nvSpPr>
         <p:spPr>
           <a:xfrm xmlns:a="http://schemas.openxmlformats.org/drawingml/2006/main">
-            <a:off x="595071" y="3523400"/>
-            <a:ext cx="3704493" cy="2290259"/>
+            <a:off x="595027" y="3429000"/>
+            <a:ext cx="3704463" cy="3048000"/>
           </a:xfrm>
           <a:prstGeom xmlns:a="http://schemas.openxmlformats.org/drawingml/2006/main" prst="rect">
             <a:avLst/>
@@ -32484,35 +32500,39 @@
                 <a:ea typeface="Arial"/>
                 <a:cs typeface="Arial"/>
               </a:rPr>
-              <a:t>CAPTURA PENDIENTE</a:t>
-            </a:r>
-          </a:p>
-          <a:p xmlns:a="http://schemas.openxmlformats.org/drawingml/2006/main">
-            <a:pPr algn="ctr">
-              <a:buNone/>
-            </a:pPr>
-            <a:r>
-              <a:rPr sz="900" i="1">
-                <a:solidFill>
-                  <a:srgbClr val="666666"/>
-                </a:solidFill>
-                <a:latin typeface="Arial"/>
-                <a:ea typeface="Arial"/>
-                <a:cs typeface="Arial"/>
-              </a:rPr>
-              <a:t>Pantalla móvil de inicio de sesión</a:t>
-            </a:r>
-            <a:endParaRPr sz="900" i="1">
-              <a:solidFill>
-                <a:srgbClr val="666666"/>
-              </a:solidFill>
-              <a:latin typeface="Arial"/>
-              <a:ea typeface="Arial"/>
-              <a:cs typeface="Arial"/>
-            </a:endParaRPr>
+              <a:t/>
+            </a:r>
           </a:p>
         </p:txBody>
       </p:sp>
+      <p:pic>
+        <p:nvPicPr>
+          <p:cNvPr id="459" name="">
+            <a:extLst xmlns:a="http://schemas.openxmlformats.org/drawingml/2006/main">
+              <a:ext uri="{FF2B5EF4-FFF2-40B4-BE49-F238E27FC236}">
+                <a16:creationId xmlns:a16="http://schemas.microsoft.com/office/drawing/2014/main" id="{AF16AE66-E542-45EF-822A-85C4C13B3EB3}"/>
+              </a:ext>
+            </a:extLst>
+          </p:cNvPr>
+          <p:cNvPicPr>
+            <a:picLocks xmlns:a="http://schemas.openxmlformats.org/drawingml/2006/main" noChangeAspect="1"/>
+          </p:cNvPicPr>
+          <p:nvPr/>
+        </p:nvPicPr>
+        <p:blipFill>
+          <a:blip xmlns:r="http://schemas.openxmlformats.org/officeDocument/2006/relationships" xmlns:a="http://schemas.openxmlformats.org/drawingml/2006/main" r:embed="Rab1e282378144768"/>
+          <a:stretch xmlns:a="http://schemas.openxmlformats.org/drawingml/2006/main"/>
+        </p:blipFill>
+        <p:spPr>
+          <a:xfrm xmlns:a="http://schemas.openxmlformats.org/drawingml/2006/main">
+            <a:off x="1783556" y="3476625"/>
+            <a:ext cx="1328738" cy="2952750"/>
+          </a:xfrm>
+          <a:prstGeom xmlns:a="http://schemas.openxmlformats.org/drawingml/2006/main" prst="rect">
+            <a:avLst/>
+          </a:prstGeom>
+        </p:spPr>
+      </p:pic>
     </p:spTree>
     <p:extLst>
       <p:ext uri="{BB962C8B-B14F-4D97-AF65-F5344CB8AC3E}">

</xml_diff>